<commit_message>
Rebuild every report and deck with ImpactMojo as publisher
Co-Authored-By: Claude Opus 5.5 <noreply@anthropic.com>
Claude-Session: https://claude.ai/code/session_012JjD5mhtvLxzAXoZHMZYE5
</commit_message>
<xml_diff>
--- a/reports/assam-special-revision-2026-deck.pptx
+++ b/reports/assam-special-revision-2026-deck.pptx
@@ -1948,7 +1948,7 @@
       </p:sp>
       <p:pic>
         <p:nvPicPr>
-          <p:cNvPr id="4" name="Image 0" descr="/tmp/pack-8Tsy5x/as-assam-1.png">    </p:cNvPr>
+          <p:cNvPr id="4" name="Image 0" descr="/tmp/pack-7qNEwO/as-assam-1.png">    </p:cNvPr>
           <p:cNvPicPr>
             <a:picLocks noChangeAspect="1"/>
           </p:cNvPicPr>
@@ -2121,7 +2121,7 @@
       </p:sp>
       <p:pic>
         <p:nvPicPr>
-          <p:cNvPr id="4" name="Image 0" descr="/tmp/pack-8Tsy5x/as-assam-2.png">    </p:cNvPr>
+          <p:cNvPr id="4" name="Image 0" descr="/tmp/pack-7qNEwO/as-assam-2.png">    </p:cNvPr>
           <p:cNvPicPr>
             <a:picLocks noChangeAspect="1"/>
           </p:cNvPicPr>
@@ -2333,7 +2333,7 @@
       </p:sp>
       <p:pic>
         <p:nvPicPr>
-          <p:cNvPr id="4" name="Image 0" descr="/tmp/pack-8Tsy5x/as-assam-3.png">    </p:cNvPr>
+          <p:cNvPr id="4" name="Image 0" descr="/tmp/pack-7qNEwO/as-assam-3.png">    </p:cNvPr>
           <p:cNvPicPr>
             <a:picLocks noChangeAspect="1"/>
           </p:cNvPicPr>
@@ -2506,7 +2506,7 @@
       </p:sp>
       <p:pic>
         <p:nvPicPr>
-          <p:cNvPr id="4" name="Image 0" descr="/tmp/pack-8Tsy5x/as-assam-4.png">    </p:cNvPr>
+          <p:cNvPr id="4" name="Image 0" descr="/tmp/pack-7qNEwO/as-assam-4.png">    </p:cNvPr>
           <p:cNvPicPr>
             <a:picLocks noChangeAspect="1"/>
           </p:cNvPicPr>
@@ -2679,7 +2679,7 @@
       </p:sp>
       <p:pic>
         <p:nvPicPr>
-          <p:cNvPr id="4" name="Image 0" descr="/tmp/pack-8Tsy5x/as-assam-5.png">    </p:cNvPr>
+          <p:cNvPr id="4" name="Image 0" descr="/tmp/pack-7qNEwO/as-assam-5.png">    </p:cNvPr>
           <p:cNvPicPr>
             <a:picLocks noChangeAspect="1"/>
           </p:cNvPicPr>
@@ -2852,7 +2852,7 @@
       </p:sp>
       <p:pic>
         <p:nvPicPr>
-          <p:cNvPr id="4" name="Image 0" descr="/tmp/pack-8Tsy5x/as-assam-6.png">    </p:cNvPr>
+          <p:cNvPr id="4" name="Image 0" descr="/tmp/pack-7qNEwO/as-assam-6.png">    </p:cNvPr>
           <p:cNvPicPr>
             <a:picLocks noChangeAspect="1"/>
           </p:cNvPicPr>
@@ -3025,7 +3025,7 @@
       </p:sp>
       <p:pic>
         <p:nvPicPr>
-          <p:cNvPr id="4" name="Image 0" descr="/tmp/pack-8Tsy5x/as-assam-7.png">    </p:cNvPr>
+          <p:cNvPr id="4" name="Image 0" descr="/tmp/pack-7qNEwO/as-assam-7.png">    </p:cNvPr>
           <p:cNvPicPr>
             <a:picLocks noChangeAspect="1"/>
           </p:cNvPicPr>

</xml_diff>

<commit_message>
Reports: rebuild in progress (work in progress)
Co-Authored-By: Claude Opus 5.5 <noreply@anthropic.com>
Claude-Session: https://claude.ai/code/session_012JjD5mhtvLxzAXoZHMZYE5
</commit_message>
<xml_diff>
--- a/reports/assam-special-revision-2026-deck.pptx
+++ b/reports/assam-special-revision-2026-deck.pptx
@@ -598,7 +598,7 @@
           <a:p>
             <a:r>
               <a:rPr lang="en-US" dirty="0"/>
-              <a:t>The draft roll held 2,76,490 more names than the roll of January 2025, and the final roll 2,44,636 fewer than the draft. The final roll of 2.50 crore electors is 31,854 larger than the roll of January 2025. Women are 49.99% of it. The January 2025 figure is the Chief Electoral Officer's as reported in the press, and the Commission published no count of the names added and removed in between, only the totals.</a:t>
+              <a:t>The draft roll held 2,76,490 more names than the roll of January 2025, and the final roll 2,44,636 fewer than the draft. The final roll of 2.50 crore electors is 31,854 larger than the roll of January 2025. Women are 49.99% of it. The January 2025 figure is the Chief Electoral Officer's as reported in the press, and the Commission published no count of the names added and deleted in between, only the totals.</a:t>
             </a:r>
             <a:endParaRPr lang="en-US" dirty="0"/>
           </a:p>
@@ -1948,7 +1948,7 @@
       </p:sp>
       <p:pic>
         <p:nvPicPr>
-          <p:cNvPr id="4" name="Image 0" descr="/tmp/pack-7qNEwO/as-assam-1.png">    </p:cNvPr>
+          <p:cNvPr id="4" name="Image 0" descr="/tmp/pack-BpyxFC/as-assam-1.png">    </p:cNvPr>
           <p:cNvPicPr>
             <a:picLocks noChangeAspect="1"/>
           </p:cNvPicPr>
@@ -2121,7 +2121,7 @@
       </p:sp>
       <p:pic>
         <p:nvPicPr>
-          <p:cNvPr id="4" name="Image 0" descr="/tmp/pack-7qNEwO/as-assam-2.png">    </p:cNvPr>
+          <p:cNvPr id="4" name="Image 0" descr="/tmp/pack-BpyxFC/as-assam-2.png">    </p:cNvPr>
           <p:cNvPicPr>
             <a:picLocks noChangeAspect="1"/>
           </p:cNvPicPr>
@@ -2333,7 +2333,7 @@
       </p:sp>
       <p:pic>
         <p:nvPicPr>
-          <p:cNvPr id="4" name="Image 0" descr="/tmp/pack-7qNEwO/as-assam-3.png">    </p:cNvPr>
+          <p:cNvPr id="4" name="Image 0" descr="/tmp/pack-BpyxFC/as-assam-3.png">    </p:cNvPr>
           <p:cNvPicPr>
             <a:picLocks noChangeAspect="1"/>
           </p:cNvPicPr>
@@ -2506,7 +2506,7 @@
       </p:sp>
       <p:pic>
         <p:nvPicPr>
-          <p:cNvPr id="4" name="Image 0" descr="/tmp/pack-7qNEwO/as-assam-4.png">    </p:cNvPr>
+          <p:cNvPr id="4" name="Image 0" descr="/tmp/pack-BpyxFC/as-assam-4.png">    </p:cNvPr>
           <p:cNvPicPr>
             <a:picLocks noChangeAspect="1"/>
           </p:cNvPicPr>
@@ -2679,7 +2679,7 @@
       </p:sp>
       <p:pic>
         <p:nvPicPr>
-          <p:cNvPr id="4" name="Image 0" descr="/tmp/pack-7qNEwO/as-assam-5.png">    </p:cNvPr>
+          <p:cNvPr id="4" name="Image 0" descr="/tmp/pack-BpyxFC/as-assam-5.png">    </p:cNvPr>
           <p:cNvPicPr>
             <a:picLocks noChangeAspect="1"/>
           </p:cNvPicPr>
@@ -2852,7 +2852,7 @@
       </p:sp>
       <p:pic>
         <p:nvPicPr>
-          <p:cNvPr id="4" name="Image 0" descr="/tmp/pack-7qNEwO/as-assam-6.png">    </p:cNvPr>
+          <p:cNvPr id="4" name="Image 0" descr="/tmp/pack-BpyxFC/as-assam-6.png">    </p:cNvPr>
           <p:cNvPicPr>
             <a:picLocks noChangeAspect="1"/>
           </p:cNvPicPr>
@@ -3025,7 +3025,7 @@
       </p:sp>
       <p:pic>
         <p:nvPicPr>
-          <p:cNvPr id="4" name="Image 0" descr="/tmp/pack-7qNEwO/as-assam-7.png">    </p:cNvPr>
+          <p:cNvPr id="4" name="Image 0" descr="/tmp/pack-BpyxFC/as-assam-7.png">    </p:cNvPr>
           <p:cNvPicPr>
             <a:picLocks noChangeAspect="1"/>
           </p:cNvPicPr>
@@ -3233,7 +3233,7 @@
                 <a:ea typeface="Calibri" pitchFamily="34" charset="-122"/>
                 <a:cs typeface="Calibri" pitchFamily="34" charset="-120"/>
               </a:rPr>
-              <a:t>The draft and final rolls by constituency are the Chief Electoral Officer's own tables, and the count of names flagged is the officer's as reported in the press. The constituency tables give the net change only. A reason for deletion is what the officer wrote down, and nobody checked it. The detention figures are from 2019 and 2020.</a:t>
+              <a:t>The draft and final rolls by constituency are the Chief Electoral Officer's own tables, and the count of names flagged is the officer's as reported in the press. The constituency tables give the net change only. A reason entered for a flagged name is what the officer wrote down, and nobody checked it. The detention figures are from 2019 and 2020.</a:t>
             </a:r>
             <a:endParaRPr lang="en-US" sz="1500" dirty="0"/>
           </a:p>

</xml_diff>